<commit_message>
Point all links at the new Blue-Star-Families org
</commit_message>
<xml_diff>
--- a/Military-Pay-Estimator-Guide.pptx
+++ b/Military-Pay-Estimator-Guide.pptx
@@ -2564,7 +2564,7 @@
                 <a:ea typeface="Calibri" pitchFamily="34" charset="-122"/>
                 <a:cs typeface="Calibri" pitchFamily="34" charset="-120"/>
               </a:rPr>
-              <a:t>blue-star-families1.github.io/military-pay-calculator</a:t>
+              <a:t>blue-star-families.github.io/military-pay-calculator</a:t>
             </a:r>
             <a:endParaRPr lang="en-US" sz="1200" dirty="0"/>
           </a:p>
@@ -3420,7 +3420,7 @@
                 <a:ea typeface="Calibri" pitchFamily="34" charset="-122"/>
                 <a:cs typeface="Calibri" pitchFamily="34" charset="-120"/>
               </a:rPr>
-              <a:t>blue-star-families1.github.io/military-pay-calculator</a:t>
+              <a:t>blue-star-families.github.io/military-pay-calculator</a:t>
             </a:r>
             <a:endParaRPr lang="en-US" sz="900" dirty="0"/>
           </a:p>
@@ -4424,7 +4424,7 @@
                 <a:ea typeface="Calibri" pitchFamily="34" charset="-122"/>
                 <a:cs typeface="Calibri" pitchFamily="34" charset="-120"/>
               </a:rPr>
-              <a:t>blue-star-families1.github.io/military-pay-calculator</a:t>
+              <a:t>blue-star-families.github.io/military-pay-calculator</a:t>
             </a:r>
             <a:endParaRPr lang="en-US" sz="900" dirty="0"/>
           </a:p>
@@ -5181,7 +5181,7 @@
                 <a:ea typeface="Calibri" pitchFamily="34" charset="-122"/>
                 <a:cs typeface="Calibri" pitchFamily="34" charset="-120"/>
               </a:rPr>
-              <a:t>blue-star-families1.github.io/military-pay-calculator</a:t>
+              <a:t>blue-star-families.github.io/military-pay-calculator</a:t>
             </a:r>
             <a:endParaRPr lang="en-US" sz="900" dirty="0"/>
           </a:p>
@@ -5905,7 +5905,7 @@
                 <a:ea typeface="Calibri" pitchFamily="34" charset="-122"/>
                 <a:cs typeface="Calibri" pitchFamily="34" charset="-120"/>
               </a:rPr>
-              <a:t>blue-star-families1.github.io/military-pay-calculator</a:t>
+              <a:t>blue-star-families.github.io/military-pay-calculator</a:t>
             </a:r>
             <a:endParaRPr lang="en-US" sz="1400" dirty="0"/>
           </a:p>
@@ -6159,7 +6159,7 @@
                 <a:ea typeface="Calibri" pitchFamily="34" charset="-122"/>
                 <a:cs typeface="Calibri" pitchFamily="34" charset="-120"/>
               </a:rPr>
-              <a:t>blue-star-families1.github.io/military-pay-calculator</a:t>
+              <a:t>blue-star-families.github.io/military-pay-calculator</a:t>
             </a:r>
             <a:endParaRPr lang="en-US" sz="1250" dirty="0"/>
           </a:p>
@@ -6972,7 +6972,7 @@
                 <a:ea typeface="Calibri" pitchFamily="34" charset="-122"/>
                 <a:cs typeface="Calibri" pitchFamily="34" charset="-120"/>
               </a:rPr>
-              <a:t>blue-star-families1.github.io/military-pay-calculator</a:t>
+              <a:t>blue-star-families.github.io/military-pay-calculator</a:t>
             </a:r>
             <a:endParaRPr lang="en-US" sz="900" dirty="0"/>
           </a:p>
@@ -7553,7 +7553,7 @@
                 <a:ea typeface="Calibri" pitchFamily="34" charset="-122"/>
                 <a:cs typeface="Calibri" pitchFamily="34" charset="-120"/>
               </a:rPr>
-              <a:t>blue-star-families1.github.io/military-pay-calculator</a:t>
+              <a:t>blue-star-families.github.io/military-pay-calculator</a:t>
             </a:r>
             <a:endParaRPr lang="en-US" sz="900" dirty="0"/>
           </a:p>
@@ -8502,7 +8502,7 @@
                 <a:ea typeface="Calibri" pitchFamily="34" charset="-122"/>
                 <a:cs typeface="Calibri" pitchFamily="34" charset="-120"/>
               </a:rPr>
-              <a:t>blue-star-families1.github.io/military-pay-calculator</a:t>
+              <a:t>blue-star-families.github.io/military-pay-calculator</a:t>
             </a:r>
             <a:endParaRPr lang="en-US" sz="900" dirty="0"/>
           </a:p>
@@ -9385,7 +9385,7 @@
                 <a:ea typeface="Calibri" pitchFamily="34" charset="-122"/>
                 <a:cs typeface="Calibri" pitchFamily="34" charset="-120"/>
               </a:rPr>
-              <a:t>blue-star-families1.github.io/military-pay-calculator</a:t>
+              <a:t>blue-star-families.github.io/military-pay-calculator</a:t>
             </a:r>
             <a:endParaRPr lang="en-US" sz="900" dirty="0"/>
           </a:p>
@@ -10434,7 +10434,7 @@
                 <a:ea typeface="Calibri" pitchFamily="34" charset="-122"/>
                 <a:cs typeface="Calibri" pitchFamily="34" charset="-120"/>
               </a:rPr>
-              <a:t>blue-star-families1.github.io/military-pay-calculator</a:t>
+              <a:t>blue-star-families.github.io/military-pay-calculator</a:t>
             </a:r>
             <a:endParaRPr lang="en-US" sz="900" dirty="0"/>
           </a:p>
@@ -12046,7 +12046,7 @@
                 <a:ea typeface="Calibri" pitchFamily="34" charset="-122"/>
                 <a:cs typeface="Calibri" pitchFamily="34" charset="-120"/>
               </a:rPr>
-              <a:t>blue-star-families1.github.io/military-pay-calculator</a:t>
+              <a:t>blue-star-families.github.io/military-pay-calculator</a:t>
             </a:r>
             <a:endParaRPr lang="en-US" sz="900" dirty="0"/>
           </a:p>
@@ -13053,7 +13053,7 @@
                 <a:ea typeface="Calibri" pitchFamily="34" charset="-122"/>
                 <a:cs typeface="Calibri" pitchFamily="34" charset="-120"/>
               </a:rPr>
-              <a:t>blue-star-families1.github.io/military-pay-calculator</a:t>
+              <a:t>blue-star-families.github.io/military-pay-calculator</a:t>
             </a:r>
             <a:endParaRPr lang="en-US" sz="900" dirty="0"/>
           </a:p>
@@ -14478,7 +14478,7 @@
                 <a:ea typeface="Calibri" pitchFamily="34" charset="-122"/>
                 <a:cs typeface="Calibri" pitchFamily="34" charset="-120"/>
               </a:rPr>
-              <a:t>blue-star-families1.github.io/military-pay-calculator</a:t>
+              <a:t>blue-star-families.github.io/military-pay-calculator</a:t>
             </a:r>
             <a:endParaRPr lang="en-US" sz="900" dirty="0"/>
           </a:p>
@@ -15528,7 +15528,7 @@
                 <a:ea typeface="Calibri" pitchFamily="34" charset="-122"/>
                 <a:cs typeface="Calibri" pitchFamily="34" charset="-120"/>
               </a:rPr>
-              <a:t>blue-star-families1.github.io/military-pay-calculator</a:t>
+              <a:t>blue-star-families.github.io/military-pay-calculator</a:t>
             </a:r>
             <a:endParaRPr lang="en-US" sz="900" dirty="0"/>
           </a:p>

</xml_diff>